<commit_message>
Dev font/size preview + canvas pan margin + diary-tab spec annotations (v1.45.0)
- Add Pretendard font (res/font/pretendard_*.otf, theme Pretendard family).
- Settings > 개발자: DevPreviewScreen shows Pretendard/Cavorting at
  10-120sp (step 5) and squares 10-200dp (step 10) to eyeball real sizes.
- BrushView.clampAndRefresh now allows up to half the view as pan margin,
  so a zoomed canvas corner can be dragged to the screen centre for easier
  edge drawing. Canvas pixel size unchanged.
- dev/DevAnno.kt: temporary spec overlay toggled by DevAnno.SHOW. Modifier
  .devBounds records element bounds; DevAnnoOverlay draws Pretendard labels
  + leader lines. Calendar tab (slide 2) is annotated with our sp/dp values
  (year 60sp, month 100sp, arrows 35dp, weekday 25sp, day 21sp, today 38dp,
  side margin 24dp). Remove everything via DevAnno.SHOW = false.

Co-Authored-By: Claude Sonnet 5 <noreply@anthropic.com>
</commit_message>
<xml_diff>
--- a/image/UI design/세로모드.pptx
+++ b/image/UI design/세로모드.pptx
@@ -267,7 +267,7 @@
           <a:p>
             <a:fld id="{8D0BE790-B84C-4C6E-90A5-3ECCE5FA4BA5}" type="datetimeFigureOut">
               <a:rPr lang="ko-KR" altLang="en-US" smtClean="0"/>
-              <a:t>2026-08-13</a:t>
+              <a:t>2026-08-14</a:t>
             </a:fld>
             <a:endParaRPr lang="ko-KR" altLang="en-US"/>
           </a:p>
@@ -1206,7 +1206,7 @@
           <a:p>
             <a:fld id="{32914371-07C9-42DD-AB34-11C3B1CEF327}" type="datetimeFigureOut">
               <a:rPr lang="ko-KR" altLang="en-US" smtClean="0"/>
-              <a:t>2026-08-13</a:t>
+              <a:t>2026-08-14</a:t>
             </a:fld>
             <a:endParaRPr lang="ko-KR" altLang="en-US"/>
           </a:p>
@@ -1392,7 +1392,7 @@
           <a:p>
             <a:fld id="{32914371-07C9-42DD-AB34-11C3B1CEF327}" type="datetimeFigureOut">
               <a:rPr lang="ko-KR" altLang="en-US" smtClean="0"/>
-              <a:t>2026-08-13</a:t>
+              <a:t>2026-08-14</a:t>
             </a:fld>
             <a:endParaRPr lang="ko-KR" altLang="en-US"/>
           </a:p>
@@ -1572,7 +1572,7 @@
           <a:p>
             <a:fld id="{32914371-07C9-42DD-AB34-11C3B1CEF327}" type="datetimeFigureOut">
               <a:rPr lang="ko-KR" altLang="en-US" smtClean="0"/>
-              <a:t>2026-08-13</a:t>
+              <a:t>2026-08-14</a:t>
             </a:fld>
             <a:endParaRPr lang="ko-KR" altLang="en-US"/>
           </a:p>
@@ -1742,7 +1742,7 @@
           <a:p>
             <a:fld id="{32914371-07C9-42DD-AB34-11C3B1CEF327}" type="datetimeFigureOut">
               <a:rPr lang="ko-KR" altLang="en-US" smtClean="0"/>
-              <a:t>2026-08-13</a:t>
+              <a:t>2026-08-14</a:t>
             </a:fld>
             <a:endParaRPr lang="ko-KR" altLang="en-US"/>
           </a:p>
@@ -1988,7 +1988,7 @@
           <a:p>
             <a:fld id="{32914371-07C9-42DD-AB34-11C3B1CEF327}" type="datetimeFigureOut">
               <a:rPr lang="ko-KR" altLang="en-US" smtClean="0"/>
-              <a:t>2026-08-13</a:t>
+              <a:t>2026-08-14</a:t>
             </a:fld>
             <a:endParaRPr lang="ko-KR" altLang="en-US"/>
           </a:p>
@@ -2220,7 +2220,7 @@
           <a:p>
             <a:fld id="{32914371-07C9-42DD-AB34-11C3B1CEF327}" type="datetimeFigureOut">
               <a:rPr lang="ko-KR" altLang="en-US" smtClean="0"/>
-              <a:t>2026-08-13</a:t>
+              <a:t>2026-08-14</a:t>
             </a:fld>
             <a:endParaRPr lang="ko-KR" altLang="en-US"/>
           </a:p>
@@ -2587,7 +2587,7 @@
           <a:p>
             <a:fld id="{32914371-07C9-42DD-AB34-11C3B1CEF327}" type="datetimeFigureOut">
               <a:rPr lang="ko-KR" altLang="en-US" smtClean="0"/>
-              <a:t>2026-08-13</a:t>
+              <a:t>2026-08-14</a:t>
             </a:fld>
             <a:endParaRPr lang="ko-KR" altLang="en-US"/>
           </a:p>
@@ -2705,7 +2705,7 @@
           <a:p>
             <a:fld id="{32914371-07C9-42DD-AB34-11C3B1CEF327}" type="datetimeFigureOut">
               <a:rPr lang="ko-KR" altLang="en-US" smtClean="0"/>
-              <a:t>2026-08-13</a:t>
+              <a:t>2026-08-14</a:t>
             </a:fld>
             <a:endParaRPr lang="ko-KR" altLang="en-US"/>
           </a:p>
@@ -2800,7 +2800,7 @@
           <a:p>
             <a:fld id="{32914371-07C9-42DD-AB34-11C3B1CEF327}" type="datetimeFigureOut">
               <a:rPr lang="ko-KR" altLang="en-US" smtClean="0"/>
-              <a:t>2026-08-13</a:t>
+              <a:t>2026-08-14</a:t>
             </a:fld>
             <a:endParaRPr lang="ko-KR" altLang="en-US"/>
           </a:p>
@@ -3077,7 +3077,7 @@
           <a:p>
             <a:fld id="{32914371-07C9-42DD-AB34-11C3B1CEF327}" type="datetimeFigureOut">
               <a:rPr lang="ko-KR" altLang="en-US" smtClean="0"/>
-              <a:t>2026-08-13</a:t>
+              <a:t>2026-08-14</a:t>
             </a:fld>
             <a:endParaRPr lang="ko-KR" altLang="en-US"/>
           </a:p>
@@ -3334,7 +3334,7 @@
           <a:p>
             <a:fld id="{32914371-07C9-42DD-AB34-11C3B1CEF327}" type="datetimeFigureOut">
               <a:rPr lang="ko-KR" altLang="en-US" smtClean="0"/>
-              <a:t>2026-08-13</a:t>
+              <a:t>2026-08-14</a:t>
             </a:fld>
             <a:endParaRPr lang="ko-KR" altLang="en-US"/>
           </a:p>
@@ -3547,7 +3547,7 @@
           <a:p>
             <a:fld id="{32914371-07C9-42DD-AB34-11C3B1CEF327}" type="datetimeFigureOut">
               <a:rPr lang="ko-KR" altLang="en-US" smtClean="0"/>
-              <a:t>2026-08-13</a:t>
+              <a:t>2026-08-14</a:t>
             </a:fld>
             <a:endParaRPr lang="ko-KR" altLang="en-US"/>
           </a:p>
@@ -4215,11 +4215,14 @@
               <a:gd name="adj" fmla="val 50000"/>
             </a:avLst>
           </a:prstGeom>
-          <a:solidFill>
-            <a:schemeClr val="tx1"/>
-          </a:solidFill>
-          <a:ln>
-            <a:noFill/>
+          <a:noFill/>
+          <a:ln w="25400">
+            <a:solidFill>
+              <a:schemeClr val="tx1">
+                <a:lumMod val="75000"/>
+                <a:lumOff val="25000"/>
+              </a:schemeClr>
+            </a:solidFill>
           </a:ln>
         </p:spPr>
         <p:style>
@@ -4373,7 +4376,10 @@
             <a:r>
               <a:rPr lang="en-US" altLang="ko-KR" sz="2400" dirty="0">
                 <a:solidFill>
-                  <a:srgbClr val="E6E9DE"/>
+                  <a:schemeClr val="tx1">
+                    <a:lumMod val="75000"/>
+                    <a:lumOff val="25000"/>
+                  </a:schemeClr>
                 </a:solidFill>
                 <a:latin typeface="Pretendard Medium" panose="02000603000000020004" pitchFamily="50" charset="-127"/>
                 <a:ea typeface="Pretendard Medium" panose="02000603000000020004" pitchFamily="50" charset="-127"/>
@@ -4383,7 +4389,10 @@
             </a:r>
             <a:endParaRPr lang="ko-KR" altLang="en-US" sz="2400" dirty="0">
               <a:solidFill>
-                <a:srgbClr val="E6E9DE"/>
+                <a:schemeClr val="tx1">
+                  <a:lumMod val="75000"/>
+                  <a:lumOff val="25000"/>
+                </a:schemeClr>
               </a:solidFill>
               <a:latin typeface="Pretendard Medium" panose="02000603000000020004" pitchFamily="50" charset="-127"/>
               <a:ea typeface="Pretendard Medium" panose="02000603000000020004" pitchFamily="50" charset="-127"/>
@@ -4868,6 +4877,208 @@
                 </a:schemeClr>
               </a:solidFill>
               <a:latin typeface="Cavorting" panose="000B0504000000000004" pitchFamily="34" charset="0"/>
+            </a:endParaRPr>
+          </a:p>
+        </p:txBody>
+      </p:sp>
+      <p:sp>
+        <p:nvSpPr>
+          <p:cNvPr id="4" name="사각형: 둥근 모서리 3">
+            <a:extLst>
+              <a:ext uri="{FF2B5EF4-FFF2-40B4-BE49-F238E27FC236}">
+                <a16:creationId xmlns:a16="http://schemas.microsoft.com/office/drawing/2014/main" id="{1E487830-918C-BE83-3719-D753A798890C}"/>
+              </a:ext>
+            </a:extLst>
+          </p:cNvPr>
+          <p:cNvSpPr/>
+          <p:nvPr/>
+        </p:nvSpPr>
+        <p:spPr>
+          <a:xfrm flipV="1">
+            <a:off x="7194883" y="8084241"/>
+            <a:ext cx="1727736" cy="627959"/>
+          </a:xfrm>
+          <a:prstGeom prst="roundRect">
+            <a:avLst>
+              <a:gd name="adj" fmla="val 50000"/>
+            </a:avLst>
+          </a:prstGeom>
+          <a:solidFill>
+            <a:schemeClr val="tx1">
+              <a:lumMod val="75000"/>
+              <a:lumOff val="25000"/>
+            </a:schemeClr>
+          </a:solidFill>
+          <a:ln w="25400">
+            <a:noFill/>
+          </a:ln>
+        </p:spPr>
+        <p:style>
+          <a:lnRef idx="2">
+            <a:schemeClr val="accent1">
+              <a:shade val="15000"/>
+            </a:schemeClr>
+          </a:lnRef>
+          <a:fillRef idx="1">
+            <a:schemeClr val="accent1"/>
+          </a:fillRef>
+          <a:effectRef idx="0">
+            <a:schemeClr val="accent1"/>
+          </a:effectRef>
+          <a:fontRef idx="minor">
+            <a:schemeClr val="lt1"/>
+          </a:fontRef>
+        </p:style>
+        <p:txBody>
+          <a:bodyPr rtlCol="0" anchor="ctr"/>
+          <a:lstStyle/>
+          <a:p>
+            <a:pPr algn="ctr"/>
+            <a:endParaRPr lang="ko-KR" altLang="en-US" sz="2783"/>
+          </a:p>
+        </p:txBody>
+      </p:sp>
+      <p:sp>
+        <p:nvSpPr>
+          <p:cNvPr id="6" name="TextBox 5">
+            <a:extLst>
+              <a:ext uri="{FF2B5EF4-FFF2-40B4-BE49-F238E27FC236}">
+                <a16:creationId xmlns:a16="http://schemas.microsoft.com/office/drawing/2014/main" id="{7A06EAD6-BACB-4FD8-BA86-51EEE19FF5A3}"/>
+              </a:ext>
+            </a:extLst>
+          </p:cNvPr>
+          <p:cNvSpPr txBox="1"/>
+          <p:nvPr/>
+        </p:nvSpPr>
+        <p:spPr>
+          <a:xfrm>
+            <a:off x="7190072" y="8167388"/>
+            <a:ext cx="1737360" cy="461665"/>
+          </a:xfrm>
+          <a:prstGeom prst="rect">
+            <a:avLst/>
+          </a:prstGeom>
+          <a:noFill/>
+        </p:spPr>
+        <p:txBody>
+          <a:bodyPr wrap="square">
+            <a:spAutoFit/>
+          </a:bodyPr>
+          <a:lstStyle>
+            <a:defPPr>
+              <a:defRPr lang="en-US"/>
+            </a:defPPr>
+            <a:lvl1pPr marL="0" algn="l" defTabSz="457200" rtl="0" eaLnBrk="1" latinLnBrk="0" hangingPunct="1">
+              <a:defRPr sz="1800" kern="1200">
+                <a:solidFill>
+                  <a:schemeClr val="tx1"/>
+                </a:solidFill>
+                <a:latin typeface="+mn-lt"/>
+                <a:ea typeface="+mn-ea"/>
+                <a:cs typeface="+mn-cs"/>
+              </a:defRPr>
+            </a:lvl1pPr>
+            <a:lvl2pPr marL="457200" algn="l" defTabSz="457200" rtl="0" eaLnBrk="1" latinLnBrk="0" hangingPunct="1">
+              <a:defRPr sz="1800" kern="1200">
+                <a:solidFill>
+                  <a:schemeClr val="tx1"/>
+                </a:solidFill>
+                <a:latin typeface="+mn-lt"/>
+                <a:ea typeface="+mn-ea"/>
+                <a:cs typeface="+mn-cs"/>
+              </a:defRPr>
+            </a:lvl2pPr>
+            <a:lvl3pPr marL="914400" algn="l" defTabSz="457200" rtl="0" eaLnBrk="1" latinLnBrk="0" hangingPunct="1">
+              <a:defRPr sz="1800" kern="1200">
+                <a:solidFill>
+                  <a:schemeClr val="tx1"/>
+                </a:solidFill>
+                <a:latin typeface="+mn-lt"/>
+                <a:ea typeface="+mn-ea"/>
+                <a:cs typeface="+mn-cs"/>
+              </a:defRPr>
+            </a:lvl3pPr>
+            <a:lvl4pPr marL="1371600" algn="l" defTabSz="457200" rtl="0" eaLnBrk="1" latinLnBrk="0" hangingPunct="1">
+              <a:defRPr sz="1800" kern="1200">
+                <a:solidFill>
+                  <a:schemeClr val="tx1"/>
+                </a:solidFill>
+                <a:latin typeface="+mn-lt"/>
+                <a:ea typeface="+mn-ea"/>
+                <a:cs typeface="+mn-cs"/>
+              </a:defRPr>
+            </a:lvl4pPr>
+            <a:lvl5pPr marL="1828800" algn="l" defTabSz="457200" rtl="0" eaLnBrk="1" latinLnBrk="0" hangingPunct="1">
+              <a:defRPr sz="1800" kern="1200">
+                <a:solidFill>
+                  <a:schemeClr val="tx1"/>
+                </a:solidFill>
+                <a:latin typeface="+mn-lt"/>
+                <a:ea typeface="+mn-ea"/>
+                <a:cs typeface="+mn-cs"/>
+              </a:defRPr>
+            </a:lvl5pPr>
+            <a:lvl6pPr marL="2286000" algn="l" defTabSz="457200" rtl="0" eaLnBrk="1" latinLnBrk="0" hangingPunct="1">
+              <a:defRPr sz="1800" kern="1200">
+                <a:solidFill>
+                  <a:schemeClr val="tx1"/>
+                </a:solidFill>
+                <a:latin typeface="+mn-lt"/>
+                <a:ea typeface="+mn-ea"/>
+                <a:cs typeface="+mn-cs"/>
+              </a:defRPr>
+            </a:lvl6pPr>
+            <a:lvl7pPr marL="2743200" algn="l" defTabSz="457200" rtl="0" eaLnBrk="1" latinLnBrk="0" hangingPunct="1">
+              <a:defRPr sz="1800" kern="1200">
+                <a:solidFill>
+                  <a:schemeClr val="tx1"/>
+                </a:solidFill>
+                <a:latin typeface="+mn-lt"/>
+                <a:ea typeface="+mn-ea"/>
+                <a:cs typeface="+mn-cs"/>
+              </a:defRPr>
+            </a:lvl7pPr>
+            <a:lvl8pPr marL="3200400" algn="l" defTabSz="457200" rtl="0" eaLnBrk="1" latinLnBrk="0" hangingPunct="1">
+              <a:defRPr sz="1800" kern="1200">
+                <a:solidFill>
+                  <a:schemeClr val="tx1"/>
+                </a:solidFill>
+                <a:latin typeface="+mn-lt"/>
+                <a:ea typeface="+mn-ea"/>
+                <a:cs typeface="+mn-cs"/>
+              </a:defRPr>
+            </a:lvl8pPr>
+            <a:lvl9pPr marL="3657600" algn="l" defTabSz="457200" rtl="0" eaLnBrk="1" latinLnBrk="0" hangingPunct="1">
+              <a:defRPr sz="1800" kern="1200">
+                <a:solidFill>
+                  <a:schemeClr val="tx1"/>
+                </a:solidFill>
+                <a:latin typeface="+mn-lt"/>
+                <a:ea typeface="+mn-ea"/>
+                <a:cs typeface="+mn-cs"/>
+              </a:defRPr>
+            </a:lvl9pPr>
+          </a:lstStyle>
+          <a:p>
+            <a:pPr algn="ctr"/>
+            <a:r>
+              <a:rPr lang="en-US" altLang="ko-KR" sz="2400" dirty="0">
+                <a:solidFill>
+                  <a:srgbClr val="FAF8F4"/>
+                </a:solidFill>
+                <a:latin typeface="Pretendard Medium" panose="02000603000000020004" pitchFamily="50" charset="-127"/>
+                <a:ea typeface="Pretendard Medium" panose="02000603000000020004" pitchFamily="50" charset="-127"/>
+                <a:cs typeface="Pretendard Medium" panose="02000603000000020004" pitchFamily="50" charset="-127"/>
+              </a:rPr>
+              <a:t>continue</a:t>
+            </a:r>
+            <a:endParaRPr lang="ko-KR" altLang="en-US" sz="2400" dirty="0">
+              <a:solidFill>
+                <a:srgbClr val="FAF8F4"/>
+              </a:solidFill>
+              <a:latin typeface="Pretendard Medium" panose="02000603000000020004" pitchFamily="50" charset="-127"/>
+              <a:ea typeface="Pretendard Medium" panose="02000603000000020004" pitchFamily="50" charset="-127"/>
+              <a:cs typeface="Pretendard Medium" panose="02000603000000020004" pitchFamily="50" charset="-127"/>
             </a:endParaRPr>
           </a:p>
         </p:txBody>
@@ -21240,6 +21451,610 @@
           </p:txBody>
         </p:sp>
       </p:grpSp>
+      <p:sp>
+        <p:nvSpPr>
+          <p:cNvPr id="3" name="TextBox 2">
+            <a:extLst>
+              <a:ext uri="{FF2B5EF4-FFF2-40B4-BE49-F238E27FC236}">
+                <a16:creationId xmlns:a16="http://schemas.microsoft.com/office/drawing/2014/main" id="{A55FA3BD-45CE-30C8-271E-C354A304CF9D}"/>
+              </a:ext>
+            </a:extLst>
+          </p:cNvPr>
+          <p:cNvSpPr txBox="1"/>
+          <p:nvPr/>
+        </p:nvSpPr>
+        <p:spPr>
+          <a:xfrm>
+            <a:off x="-46187" y="4002005"/>
+            <a:ext cx="774850" cy="307777"/>
+          </a:xfrm>
+          <a:prstGeom prst="rect">
+            <a:avLst/>
+          </a:prstGeom>
+          <a:noFill/>
+        </p:spPr>
+        <p:txBody>
+          <a:bodyPr wrap="square">
+            <a:spAutoFit/>
+          </a:bodyPr>
+          <a:lstStyle>
+            <a:defPPr>
+              <a:defRPr lang="en-US"/>
+            </a:defPPr>
+            <a:lvl1pPr marL="0" algn="l" defTabSz="457200" rtl="0" eaLnBrk="1" latinLnBrk="0" hangingPunct="1">
+              <a:defRPr sz="1800" kern="1200">
+                <a:solidFill>
+                  <a:schemeClr val="tx1"/>
+                </a:solidFill>
+                <a:latin typeface="+mn-lt"/>
+                <a:ea typeface="+mn-ea"/>
+                <a:cs typeface="+mn-cs"/>
+              </a:defRPr>
+            </a:lvl1pPr>
+            <a:lvl2pPr marL="457200" algn="l" defTabSz="457200" rtl="0" eaLnBrk="1" latinLnBrk="0" hangingPunct="1">
+              <a:defRPr sz="1800" kern="1200">
+                <a:solidFill>
+                  <a:schemeClr val="tx1"/>
+                </a:solidFill>
+                <a:latin typeface="+mn-lt"/>
+                <a:ea typeface="+mn-ea"/>
+                <a:cs typeface="+mn-cs"/>
+              </a:defRPr>
+            </a:lvl2pPr>
+            <a:lvl3pPr marL="914400" algn="l" defTabSz="457200" rtl="0" eaLnBrk="1" latinLnBrk="0" hangingPunct="1">
+              <a:defRPr sz="1800" kern="1200">
+                <a:solidFill>
+                  <a:schemeClr val="tx1"/>
+                </a:solidFill>
+                <a:latin typeface="+mn-lt"/>
+                <a:ea typeface="+mn-ea"/>
+                <a:cs typeface="+mn-cs"/>
+              </a:defRPr>
+            </a:lvl3pPr>
+            <a:lvl4pPr marL="1371600" algn="l" defTabSz="457200" rtl="0" eaLnBrk="1" latinLnBrk="0" hangingPunct="1">
+              <a:defRPr sz="1800" kern="1200">
+                <a:solidFill>
+                  <a:schemeClr val="tx1"/>
+                </a:solidFill>
+                <a:latin typeface="+mn-lt"/>
+                <a:ea typeface="+mn-ea"/>
+                <a:cs typeface="+mn-cs"/>
+              </a:defRPr>
+            </a:lvl4pPr>
+            <a:lvl5pPr marL="1828800" algn="l" defTabSz="457200" rtl="0" eaLnBrk="1" latinLnBrk="0" hangingPunct="1">
+              <a:defRPr sz="1800" kern="1200">
+                <a:solidFill>
+                  <a:schemeClr val="tx1"/>
+                </a:solidFill>
+                <a:latin typeface="+mn-lt"/>
+                <a:ea typeface="+mn-ea"/>
+                <a:cs typeface="+mn-cs"/>
+              </a:defRPr>
+            </a:lvl5pPr>
+            <a:lvl6pPr marL="2286000" algn="l" defTabSz="457200" rtl="0" eaLnBrk="1" latinLnBrk="0" hangingPunct="1">
+              <a:defRPr sz="1800" kern="1200">
+                <a:solidFill>
+                  <a:schemeClr val="tx1"/>
+                </a:solidFill>
+                <a:latin typeface="+mn-lt"/>
+                <a:ea typeface="+mn-ea"/>
+                <a:cs typeface="+mn-cs"/>
+              </a:defRPr>
+            </a:lvl6pPr>
+            <a:lvl7pPr marL="2743200" algn="l" defTabSz="457200" rtl="0" eaLnBrk="1" latinLnBrk="0" hangingPunct="1">
+              <a:defRPr sz="1800" kern="1200">
+                <a:solidFill>
+                  <a:schemeClr val="tx1"/>
+                </a:solidFill>
+                <a:latin typeface="+mn-lt"/>
+                <a:ea typeface="+mn-ea"/>
+                <a:cs typeface="+mn-cs"/>
+              </a:defRPr>
+            </a:lvl7pPr>
+            <a:lvl8pPr marL="3200400" algn="l" defTabSz="457200" rtl="0" eaLnBrk="1" latinLnBrk="0" hangingPunct="1">
+              <a:defRPr sz="1800" kern="1200">
+                <a:solidFill>
+                  <a:schemeClr val="tx1"/>
+                </a:solidFill>
+                <a:latin typeface="+mn-lt"/>
+                <a:ea typeface="+mn-ea"/>
+                <a:cs typeface="+mn-cs"/>
+              </a:defRPr>
+            </a:lvl8pPr>
+            <a:lvl9pPr marL="3657600" algn="l" defTabSz="457200" rtl="0" eaLnBrk="1" latinLnBrk="0" hangingPunct="1">
+              <a:defRPr sz="1800" kern="1200">
+                <a:solidFill>
+                  <a:schemeClr val="tx1"/>
+                </a:solidFill>
+                <a:latin typeface="+mn-lt"/>
+                <a:ea typeface="+mn-ea"/>
+                <a:cs typeface="+mn-cs"/>
+              </a:defRPr>
+            </a:lvl9pPr>
+          </a:lstStyle>
+          <a:p>
+            <a:pPr algn="ctr"/>
+            <a:r>
+              <a:rPr lang="en-US" altLang="ko-KR" sz="1400" dirty="0">
+                <a:solidFill>
+                  <a:schemeClr val="tx1">
+                    <a:lumMod val="95000"/>
+                    <a:lumOff val="5000"/>
+                  </a:schemeClr>
+                </a:solidFill>
+                <a:latin typeface="Pretendard Medium" panose="02000603000000020004" pitchFamily="50" charset="-127"/>
+                <a:ea typeface="Pretendard Medium" panose="02000603000000020004" pitchFamily="50" charset="-127"/>
+                <a:cs typeface="Pretendard Medium" panose="02000603000000020004" pitchFamily="50" charset="-127"/>
+              </a:rPr>
+              <a:t>44dp</a:t>
+            </a:r>
+            <a:endParaRPr lang="ko-KR" altLang="en-US" sz="1400" dirty="0">
+              <a:solidFill>
+                <a:schemeClr val="tx1">
+                  <a:lumMod val="95000"/>
+                  <a:lumOff val="5000"/>
+                </a:schemeClr>
+              </a:solidFill>
+              <a:latin typeface="Pretendard Medium" panose="02000603000000020004" pitchFamily="50" charset="-127"/>
+              <a:ea typeface="Pretendard Medium" panose="02000603000000020004" pitchFamily="50" charset="-127"/>
+              <a:cs typeface="Pretendard Medium" panose="02000603000000020004" pitchFamily="50" charset="-127"/>
+            </a:endParaRPr>
+          </a:p>
+        </p:txBody>
+      </p:sp>
+      <p:sp>
+        <p:nvSpPr>
+          <p:cNvPr id="4" name="TextBox 3">
+            <a:extLst>
+              <a:ext uri="{FF2B5EF4-FFF2-40B4-BE49-F238E27FC236}">
+                <a16:creationId xmlns:a16="http://schemas.microsoft.com/office/drawing/2014/main" id="{D9FAE119-BF5B-6166-9A74-15B4ADC44285}"/>
+              </a:ext>
+            </a:extLst>
+          </p:cNvPr>
+          <p:cNvSpPr txBox="1"/>
+          <p:nvPr/>
+        </p:nvSpPr>
+        <p:spPr>
+          <a:xfrm>
+            <a:off x="3011549" y="8801588"/>
+            <a:ext cx="774850" cy="307777"/>
+          </a:xfrm>
+          <a:prstGeom prst="rect">
+            <a:avLst/>
+          </a:prstGeom>
+          <a:noFill/>
+        </p:spPr>
+        <p:txBody>
+          <a:bodyPr wrap="square">
+            <a:spAutoFit/>
+          </a:bodyPr>
+          <a:lstStyle>
+            <a:defPPr>
+              <a:defRPr lang="en-US"/>
+            </a:defPPr>
+            <a:lvl1pPr marL="0" algn="l" defTabSz="457200" rtl="0" eaLnBrk="1" latinLnBrk="0" hangingPunct="1">
+              <a:defRPr sz="1800" kern="1200">
+                <a:solidFill>
+                  <a:schemeClr val="tx1"/>
+                </a:solidFill>
+                <a:latin typeface="+mn-lt"/>
+                <a:ea typeface="+mn-ea"/>
+                <a:cs typeface="+mn-cs"/>
+              </a:defRPr>
+            </a:lvl1pPr>
+            <a:lvl2pPr marL="457200" algn="l" defTabSz="457200" rtl="0" eaLnBrk="1" latinLnBrk="0" hangingPunct="1">
+              <a:defRPr sz="1800" kern="1200">
+                <a:solidFill>
+                  <a:schemeClr val="tx1"/>
+                </a:solidFill>
+                <a:latin typeface="+mn-lt"/>
+                <a:ea typeface="+mn-ea"/>
+                <a:cs typeface="+mn-cs"/>
+              </a:defRPr>
+            </a:lvl2pPr>
+            <a:lvl3pPr marL="914400" algn="l" defTabSz="457200" rtl="0" eaLnBrk="1" latinLnBrk="0" hangingPunct="1">
+              <a:defRPr sz="1800" kern="1200">
+                <a:solidFill>
+                  <a:schemeClr val="tx1"/>
+                </a:solidFill>
+                <a:latin typeface="+mn-lt"/>
+                <a:ea typeface="+mn-ea"/>
+                <a:cs typeface="+mn-cs"/>
+              </a:defRPr>
+            </a:lvl3pPr>
+            <a:lvl4pPr marL="1371600" algn="l" defTabSz="457200" rtl="0" eaLnBrk="1" latinLnBrk="0" hangingPunct="1">
+              <a:defRPr sz="1800" kern="1200">
+                <a:solidFill>
+                  <a:schemeClr val="tx1"/>
+                </a:solidFill>
+                <a:latin typeface="+mn-lt"/>
+                <a:ea typeface="+mn-ea"/>
+                <a:cs typeface="+mn-cs"/>
+              </a:defRPr>
+            </a:lvl4pPr>
+            <a:lvl5pPr marL="1828800" algn="l" defTabSz="457200" rtl="0" eaLnBrk="1" latinLnBrk="0" hangingPunct="1">
+              <a:defRPr sz="1800" kern="1200">
+                <a:solidFill>
+                  <a:schemeClr val="tx1"/>
+                </a:solidFill>
+                <a:latin typeface="+mn-lt"/>
+                <a:ea typeface="+mn-ea"/>
+                <a:cs typeface="+mn-cs"/>
+              </a:defRPr>
+            </a:lvl5pPr>
+            <a:lvl6pPr marL="2286000" algn="l" defTabSz="457200" rtl="0" eaLnBrk="1" latinLnBrk="0" hangingPunct="1">
+              <a:defRPr sz="1800" kern="1200">
+                <a:solidFill>
+                  <a:schemeClr val="tx1"/>
+                </a:solidFill>
+                <a:latin typeface="+mn-lt"/>
+                <a:ea typeface="+mn-ea"/>
+                <a:cs typeface="+mn-cs"/>
+              </a:defRPr>
+            </a:lvl6pPr>
+            <a:lvl7pPr marL="2743200" algn="l" defTabSz="457200" rtl="0" eaLnBrk="1" latinLnBrk="0" hangingPunct="1">
+              <a:defRPr sz="1800" kern="1200">
+                <a:solidFill>
+                  <a:schemeClr val="tx1"/>
+                </a:solidFill>
+                <a:latin typeface="+mn-lt"/>
+                <a:ea typeface="+mn-ea"/>
+                <a:cs typeface="+mn-cs"/>
+              </a:defRPr>
+            </a:lvl7pPr>
+            <a:lvl8pPr marL="3200400" algn="l" defTabSz="457200" rtl="0" eaLnBrk="1" latinLnBrk="0" hangingPunct="1">
+              <a:defRPr sz="1800" kern="1200">
+                <a:solidFill>
+                  <a:schemeClr val="tx1"/>
+                </a:solidFill>
+                <a:latin typeface="+mn-lt"/>
+                <a:ea typeface="+mn-ea"/>
+                <a:cs typeface="+mn-cs"/>
+              </a:defRPr>
+            </a:lvl8pPr>
+            <a:lvl9pPr marL="3657600" algn="l" defTabSz="457200" rtl="0" eaLnBrk="1" latinLnBrk="0" hangingPunct="1">
+              <a:defRPr sz="1800" kern="1200">
+                <a:solidFill>
+                  <a:schemeClr val="tx1"/>
+                </a:solidFill>
+                <a:latin typeface="+mn-lt"/>
+                <a:ea typeface="+mn-ea"/>
+                <a:cs typeface="+mn-cs"/>
+              </a:defRPr>
+            </a:lvl9pPr>
+          </a:lstStyle>
+          <a:p>
+            <a:pPr algn="ctr"/>
+            <a:r>
+              <a:rPr lang="en-US" altLang="ko-KR" sz="1400" dirty="0">
+                <a:solidFill>
+                  <a:schemeClr val="tx1">
+                    <a:lumMod val="95000"/>
+                    <a:lumOff val="5000"/>
+                  </a:schemeClr>
+                </a:solidFill>
+                <a:latin typeface="Pretendard Medium" panose="02000603000000020004" pitchFamily="50" charset="-127"/>
+                <a:ea typeface="Pretendard Medium" panose="02000603000000020004" pitchFamily="50" charset="-127"/>
+                <a:cs typeface="Pretendard Medium" panose="02000603000000020004" pitchFamily="50" charset="-127"/>
+              </a:rPr>
+              <a:t>30dp</a:t>
+            </a:r>
+            <a:endParaRPr lang="ko-KR" altLang="en-US" sz="1400" dirty="0">
+              <a:solidFill>
+                <a:schemeClr val="tx1">
+                  <a:lumMod val="95000"/>
+                  <a:lumOff val="5000"/>
+                </a:schemeClr>
+              </a:solidFill>
+              <a:latin typeface="Pretendard Medium" panose="02000603000000020004" pitchFamily="50" charset="-127"/>
+              <a:ea typeface="Pretendard Medium" panose="02000603000000020004" pitchFamily="50" charset="-127"/>
+              <a:cs typeface="Pretendard Medium" panose="02000603000000020004" pitchFamily="50" charset="-127"/>
+            </a:endParaRPr>
+          </a:p>
+        </p:txBody>
+      </p:sp>
+      <p:sp>
+        <p:nvSpPr>
+          <p:cNvPr id="5" name="TextBox 4">
+            <a:extLst>
+              <a:ext uri="{FF2B5EF4-FFF2-40B4-BE49-F238E27FC236}">
+                <a16:creationId xmlns:a16="http://schemas.microsoft.com/office/drawing/2014/main" id="{09509E18-99CC-AE7C-4973-768E685D846E}"/>
+              </a:ext>
+            </a:extLst>
+          </p:cNvPr>
+          <p:cNvSpPr txBox="1"/>
+          <p:nvPr/>
+        </p:nvSpPr>
+        <p:spPr>
+          <a:xfrm>
+            <a:off x="3011549" y="171642"/>
+            <a:ext cx="774850" cy="307777"/>
+          </a:xfrm>
+          <a:prstGeom prst="rect">
+            <a:avLst/>
+          </a:prstGeom>
+          <a:noFill/>
+        </p:spPr>
+        <p:txBody>
+          <a:bodyPr wrap="square">
+            <a:spAutoFit/>
+          </a:bodyPr>
+          <a:lstStyle>
+            <a:defPPr>
+              <a:defRPr lang="en-US"/>
+            </a:defPPr>
+            <a:lvl1pPr marL="0" algn="l" defTabSz="457200" rtl="0" eaLnBrk="1" latinLnBrk="0" hangingPunct="1">
+              <a:defRPr sz="1800" kern="1200">
+                <a:solidFill>
+                  <a:schemeClr val="tx1"/>
+                </a:solidFill>
+                <a:latin typeface="+mn-lt"/>
+                <a:ea typeface="+mn-ea"/>
+                <a:cs typeface="+mn-cs"/>
+              </a:defRPr>
+            </a:lvl1pPr>
+            <a:lvl2pPr marL="457200" algn="l" defTabSz="457200" rtl="0" eaLnBrk="1" latinLnBrk="0" hangingPunct="1">
+              <a:defRPr sz="1800" kern="1200">
+                <a:solidFill>
+                  <a:schemeClr val="tx1"/>
+                </a:solidFill>
+                <a:latin typeface="+mn-lt"/>
+                <a:ea typeface="+mn-ea"/>
+                <a:cs typeface="+mn-cs"/>
+              </a:defRPr>
+            </a:lvl2pPr>
+            <a:lvl3pPr marL="914400" algn="l" defTabSz="457200" rtl="0" eaLnBrk="1" latinLnBrk="0" hangingPunct="1">
+              <a:defRPr sz="1800" kern="1200">
+                <a:solidFill>
+                  <a:schemeClr val="tx1"/>
+                </a:solidFill>
+                <a:latin typeface="+mn-lt"/>
+                <a:ea typeface="+mn-ea"/>
+                <a:cs typeface="+mn-cs"/>
+              </a:defRPr>
+            </a:lvl3pPr>
+            <a:lvl4pPr marL="1371600" algn="l" defTabSz="457200" rtl="0" eaLnBrk="1" latinLnBrk="0" hangingPunct="1">
+              <a:defRPr sz="1800" kern="1200">
+                <a:solidFill>
+                  <a:schemeClr val="tx1"/>
+                </a:solidFill>
+                <a:latin typeface="+mn-lt"/>
+                <a:ea typeface="+mn-ea"/>
+                <a:cs typeface="+mn-cs"/>
+              </a:defRPr>
+            </a:lvl4pPr>
+            <a:lvl5pPr marL="1828800" algn="l" defTabSz="457200" rtl="0" eaLnBrk="1" latinLnBrk="0" hangingPunct="1">
+              <a:defRPr sz="1800" kern="1200">
+                <a:solidFill>
+                  <a:schemeClr val="tx1"/>
+                </a:solidFill>
+                <a:latin typeface="+mn-lt"/>
+                <a:ea typeface="+mn-ea"/>
+                <a:cs typeface="+mn-cs"/>
+              </a:defRPr>
+            </a:lvl5pPr>
+            <a:lvl6pPr marL="2286000" algn="l" defTabSz="457200" rtl="0" eaLnBrk="1" latinLnBrk="0" hangingPunct="1">
+              <a:defRPr sz="1800" kern="1200">
+                <a:solidFill>
+                  <a:schemeClr val="tx1"/>
+                </a:solidFill>
+                <a:latin typeface="+mn-lt"/>
+                <a:ea typeface="+mn-ea"/>
+                <a:cs typeface="+mn-cs"/>
+              </a:defRPr>
+            </a:lvl6pPr>
+            <a:lvl7pPr marL="2743200" algn="l" defTabSz="457200" rtl="0" eaLnBrk="1" latinLnBrk="0" hangingPunct="1">
+              <a:defRPr sz="1800" kern="1200">
+                <a:solidFill>
+                  <a:schemeClr val="tx1"/>
+                </a:solidFill>
+                <a:latin typeface="+mn-lt"/>
+                <a:ea typeface="+mn-ea"/>
+                <a:cs typeface="+mn-cs"/>
+              </a:defRPr>
+            </a:lvl7pPr>
+            <a:lvl8pPr marL="3200400" algn="l" defTabSz="457200" rtl="0" eaLnBrk="1" latinLnBrk="0" hangingPunct="1">
+              <a:defRPr sz="1800" kern="1200">
+                <a:solidFill>
+                  <a:schemeClr val="tx1"/>
+                </a:solidFill>
+                <a:latin typeface="+mn-lt"/>
+                <a:ea typeface="+mn-ea"/>
+                <a:cs typeface="+mn-cs"/>
+              </a:defRPr>
+            </a:lvl8pPr>
+            <a:lvl9pPr marL="3657600" algn="l" defTabSz="457200" rtl="0" eaLnBrk="1" latinLnBrk="0" hangingPunct="1">
+              <a:defRPr sz="1800" kern="1200">
+                <a:solidFill>
+                  <a:schemeClr val="tx1"/>
+                </a:solidFill>
+                <a:latin typeface="+mn-lt"/>
+                <a:ea typeface="+mn-ea"/>
+                <a:cs typeface="+mn-cs"/>
+              </a:defRPr>
+            </a:lvl9pPr>
+          </a:lstStyle>
+          <a:p>
+            <a:pPr algn="ctr"/>
+            <a:r>
+              <a:rPr lang="en-US" altLang="ko-KR" sz="1400" dirty="0">
+                <a:solidFill>
+                  <a:schemeClr val="tx1">
+                    <a:lumMod val="95000"/>
+                    <a:lumOff val="5000"/>
+                  </a:schemeClr>
+                </a:solidFill>
+                <a:latin typeface="Pretendard Medium" panose="02000603000000020004" pitchFamily="50" charset="-127"/>
+                <a:ea typeface="Pretendard Medium" panose="02000603000000020004" pitchFamily="50" charset="-127"/>
+                <a:cs typeface="Pretendard Medium" panose="02000603000000020004" pitchFamily="50" charset="-127"/>
+              </a:rPr>
+              <a:t>30dp</a:t>
+            </a:r>
+            <a:endParaRPr lang="ko-KR" altLang="en-US" sz="1400" dirty="0">
+              <a:solidFill>
+                <a:schemeClr val="tx1">
+                  <a:lumMod val="95000"/>
+                  <a:lumOff val="5000"/>
+                </a:schemeClr>
+              </a:solidFill>
+              <a:latin typeface="Pretendard Medium" panose="02000603000000020004" pitchFamily="50" charset="-127"/>
+              <a:ea typeface="Pretendard Medium" panose="02000603000000020004" pitchFamily="50" charset="-127"/>
+              <a:cs typeface="Pretendard Medium" panose="02000603000000020004" pitchFamily="50" charset="-127"/>
+            </a:endParaRPr>
+          </a:p>
+        </p:txBody>
+      </p:sp>
+      <p:sp>
+        <p:nvSpPr>
+          <p:cNvPr id="10" name="TextBox 9">
+            <a:extLst>
+              <a:ext uri="{FF2B5EF4-FFF2-40B4-BE49-F238E27FC236}">
+                <a16:creationId xmlns:a16="http://schemas.microsoft.com/office/drawing/2014/main" id="{3FC192AD-35C6-DB5F-0378-CF76942AEA43}"/>
+              </a:ext>
+            </a:extLst>
+          </p:cNvPr>
+          <p:cNvSpPr txBox="1"/>
+          <p:nvPr/>
+        </p:nvSpPr>
+        <p:spPr>
+          <a:xfrm>
+            <a:off x="6091898" y="4155893"/>
+            <a:ext cx="774850" cy="307777"/>
+          </a:xfrm>
+          <a:prstGeom prst="rect">
+            <a:avLst/>
+          </a:prstGeom>
+          <a:noFill/>
+        </p:spPr>
+        <p:txBody>
+          <a:bodyPr wrap="square">
+            <a:spAutoFit/>
+          </a:bodyPr>
+          <a:lstStyle>
+            <a:defPPr>
+              <a:defRPr lang="en-US"/>
+            </a:defPPr>
+            <a:lvl1pPr marL="0" algn="l" defTabSz="457200" rtl="0" eaLnBrk="1" latinLnBrk="0" hangingPunct="1">
+              <a:defRPr sz="1800" kern="1200">
+                <a:solidFill>
+                  <a:schemeClr val="tx1"/>
+                </a:solidFill>
+                <a:latin typeface="+mn-lt"/>
+                <a:ea typeface="+mn-ea"/>
+                <a:cs typeface="+mn-cs"/>
+              </a:defRPr>
+            </a:lvl1pPr>
+            <a:lvl2pPr marL="457200" algn="l" defTabSz="457200" rtl="0" eaLnBrk="1" latinLnBrk="0" hangingPunct="1">
+              <a:defRPr sz="1800" kern="1200">
+                <a:solidFill>
+                  <a:schemeClr val="tx1"/>
+                </a:solidFill>
+                <a:latin typeface="+mn-lt"/>
+                <a:ea typeface="+mn-ea"/>
+                <a:cs typeface="+mn-cs"/>
+              </a:defRPr>
+            </a:lvl2pPr>
+            <a:lvl3pPr marL="914400" algn="l" defTabSz="457200" rtl="0" eaLnBrk="1" latinLnBrk="0" hangingPunct="1">
+              <a:defRPr sz="1800" kern="1200">
+                <a:solidFill>
+                  <a:schemeClr val="tx1"/>
+                </a:solidFill>
+                <a:latin typeface="+mn-lt"/>
+                <a:ea typeface="+mn-ea"/>
+                <a:cs typeface="+mn-cs"/>
+              </a:defRPr>
+            </a:lvl3pPr>
+            <a:lvl4pPr marL="1371600" algn="l" defTabSz="457200" rtl="0" eaLnBrk="1" latinLnBrk="0" hangingPunct="1">
+              <a:defRPr sz="1800" kern="1200">
+                <a:solidFill>
+                  <a:schemeClr val="tx1"/>
+                </a:solidFill>
+                <a:latin typeface="+mn-lt"/>
+                <a:ea typeface="+mn-ea"/>
+                <a:cs typeface="+mn-cs"/>
+              </a:defRPr>
+            </a:lvl4pPr>
+            <a:lvl5pPr marL="1828800" algn="l" defTabSz="457200" rtl="0" eaLnBrk="1" latinLnBrk="0" hangingPunct="1">
+              <a:defRPr sz="1800" kern="1200">
+                <a:solidFill>
+                  <a:schemeClr val="tx1"/>
+                </a:solidFill>
+                <a:latin typeface="+mn-lt"/>
+                <a:ea typeface="+mn-ea"/>
+                <a:cs typeface="+mn-cs"/>
+              </a:defRPr>
+            </a:lvl5pPr>
+            <a:lvl6pPr marL="2286000" algn="l" defTabSz="457200" rtl="0" eaLnBrk="1" latinLnBrk="0" hangingPunct="1">
+              <a:defRPr sz="1800" kern="1200">
+                <a:solidFill>
+                  <a:schemeClr val="tx1"/>
+                </a:solidFill>
+                <a:latin typeface="+mn-lt"/>
+                <a:ea typeface="+mn-ea"/>
+                <a:cs typeface="+mn-cs"/>
+              </a:defRPr>
+            </a:lvl6pPr>
+            <a:lvl7pPr marL="2743200" algn="l" defTabSz="457200" rtl="0" eaLnBrk="1" latinLnBrk="0" hangingPunct="1">
+              <a:defRPr sz="1800" kern="1200">
+                <a:solidFill>
+                  <a:schemeClr val="tx1"/>
+                </a:solidFill>
+                <a:latin typeface="+mn-lt"/>
+                <a:ea typeface="+mn-ea"/>
+                <a:cs typeface="+mn-cs"/>
+              </a:defRPr>
+            </a:lvl7pPr>
+            <a:lvl8pPr marL="3200400" algn="l" defTabSz="457200" rtl="0" eaLnBrk="1" latinLnBrk="0" hangingPunct="1">
+              <a:defRPr sz="1800" kern="1200">
+                <a:solidFill>
+                  <a:schemeClr val="tx1"/>
+                </a:solidFill>
+                <a:latin typeface="+mn-lt"/>
+                <a:ea typeface="+mn-ea"/>
+                <a:cs typeface="+mn-cs"/>
+              </a:defRPr>
+            </a:lvl8pPr>
+            <a:lvl9pPr marL="3657600" algn="l" defTabSz="457200" rtl="0" eaLnBrk="1" latinLnBrk="0" hangingPunct="1">
+              <a:defRPr sz="1800" kern="1200">
+                <a:solidFill>
+                  <a:schemeClr val="tx1"/>
+                </a:solidFill>
+                <a:latin typeface="+mn-lt"/>
+                <a:ea typeface="+mn-ea"/>
+                <a:cs typeface="+mn-cs"/>
+              </a:defRPr>
+            </a:lvl9pPr>
+          </a:lstStyle>
+          <a:p>
+            <a:pPr algn="ctr"/>
+            <a:r>
+              <a:rPr lang="en-US" altLang="ko-KR" sz="1400" dirty="0">
+                <a:solidFill>
+                  <a:schemeClr val="tx1">
+                    <a:lumMod val="95000"/>
+                    <a:lumOff val="5000"/>
+                  </a:schemeClr>
+                </a:solidFill>
+                <a:latin typeface="Pretendard Medium" panose="02000603000000020004" pitchFamily="50" charset="-127"/>
+                <a:ea typeface="Pretendard Medium" panose="02000603000000020004" pitchFamily="50" charset="-127"/>
+                <a:cs typeface="Pretendard Medium" panose="02000603000000020004" pitchFamily="50" charset="-127"/>
+              </a:rPr>
+              <a:t>30dp</a:t>
+            </a:r>
+            <a:endParaRPr lang="ko-KR" altLang="en-US" sz="1400" dirty="0">
+              <a:solidFill>
+                <a:schemeClr val="tx1">
+                  <a:lumMod val="95000"/>
+                  <a:lumOff val="5000"/>
+                </a:schemeClr>
+              </a:solidFill>
+              <a:latin typeface="Pretendard Medium" panose="02000603000000020004" pitchFamily="50" charset="-127"/>
+              <a:ea typeface="Pretendard Medium" panose="02000603000000020004" pitchFamily="50" charset="-127"/>
+              <a:cs typeface="Pretendard Medium" panose="02000603000000020004" pitchFamily="50" charset="-127"/>
+            </a:endParaRPr>
+          </a:p>
+        </p:txBody>
+      </p:sp>
     </p:spTree>
     <p:extLst>
       <p:ext uri="{BB962C8B-B14F-4D97-AF65-F5344CB8AC3E}">

</xml_diff>

<commit_message>
Animate onboarding duck as a GIF via Coil (v1.54.0)
Replaced the static onboarding duck (duck_walk.png) with the walking GIF
(res/raw/duck_walk.gif from image/source/duck-walk.gif). painterResource
only shows a static first frame, so added Coil (coil-compose + coil-gif)
and a shared ui/DuckWalk composable that plays it through an ImageLoader
with the GIF decoder (ImageDecoderDecoder on API 28+, GifDecoder below).
Used on both Splash and Login.

Co-Authored-By: Claude Sonnet 5 <noreply@anthropic.com>
</commit_message>
<xml_diff>
--- a/image/UI design/세로모드.pptx
+++ b/image/UI design/세로모드.pptx
@@ -13722,6 +13722,36 @@
           </a:prstGeom>
         </p:spPr>
       </p:pic>
+      <p:pic>
+        <p:nvPicPr>
+          <p:cNvPr id="3" name="그림 2">
+            <a:extLst>
+              <a:ext uri="{FF2B5EF4-FFF2-40B4-BE49-F238E27FC236}">
+                <a16:creationId xmlns:a16="http://schemas.microsoft.com/office/drawing/2014/main" id="{013E13FA-ADDE-EB6E-A3FB-7703BD1FB6E4}"/>
+              </a:ext>
+            </a:extLst>
+          </p:cNvPr>
+          <p:cNvPicPr>
+            <a:picLocks noChangeAspect="1"/>
+          </p:cNvPicPr>
+          <p:nvPr/>
+        </p:nvPicPr>
+        <p:blipFill>
+          <a:blip r:embed="rId9"/>
+          <a:stretch>
+            <a:fillRect/>
+          </a:stretch>
+        </p:blipFill>
+        <p:spPr>
+          <a:xfrm>
+            <a:off x="-1292803" y="1945512"/>
+            <a:ext cx="886437" cy="886437"/>
+          </a:xfrm>
+          <a:prstGeom prst="rect">
+            <a:avLst/>
+          </a:prstGeom>
+        </p:spPr>
+      </p:pic>
     </p:spTree>
     <p:extLst>
       <p:ext uri="{BB962C8B-B14F-4D97-AF65-F5344CB8AC3E}">

</xml_diff>